<commit_message>
Replace teacher ASK cues in ANN Lecture 4 slides
Questions are now labelled THINK, in-class activities TRY IT, and
checked answers WORKED SOLUTION.

Co-Authored-By: Claude Opus 5.5 <noreply@anthropic.com>
</commit_message>
<xml_diff>
--- a/courses/artificial-neural-networks/lectures/lecture-04/slides.pptx
+++ b/courses/artificial-neural-networks/lectures/lecture-04/slides.pptx
@@ -7042,7 +7042,7 @@
               </a:defRPr>
             </a:pPr>
             <a:r>
-              <a:t>ASK  Three minutes; keep four decimal places.</a:t>
+              <a:t>TRY IT  Three minutes; keep four decimal places.</a:t>
             </a:r>
           </a:p>
         </p:txBody>
@@ -7228,7 +7228,7 @@
               </a:defRPr>
             </a:pPr>
             <a:r>
-              <a:t>CHECKED ANSWER</a:t>
+              <a:t>WORKED SOLUTION</a:t>
             </a:r>
           </a:p>
         </p:txBody>
@@ -7449,7 +7449,7 @@
               </a:defRPr>
             </a:pPr>
             <a:r>
-              <a:t>ASK  When is a one-hot row more convenient than an index?</a:t>
+              <a:t>THINK  When is a one-hot row more convenient than an index?</a:t>
             </a:r>
           </a:p>
         </p:txBody>
@@ -9013,7 +9013,7 @@
               </a:defRPr>
             </a:pPr>
             <a:r>
-              <a:t>ASK  Four minutes; ln 2 ≈ 0.693 is a useful anchor.</a:t>
+              <a:t>TRY IT  Four minutes; ln 2 ≈ 0.693 is a useful anchor.</a:t>
             </a:r>
           </a:p>
         </p:txBody>
@@ -9199,7 +9199,7 @@
               </a:defRPr>
             </a:pPr>
             <a:r>
-              <a:t>CHECKED ANSWER</a:t>
+              <a:t>WORKED SOLUTION</a:t>
             </a:r>
           </a:p>
         </p:txBody>
@@ -9420,7 +9420,7 @@
               </a:defRPr>
             </a:pPr>
             <a:r>
-              <a:t>ASK  Two rows both predict class 0 with p_true = 0.55 and 0.95. Which loss is smaller?</a:t>
+              <a:t>THINK  Two rows both predict class 0 with p_true = 0.55 and 0.95. Which loss is smaller?</a:t>
             </a:r>
           </a:p>
         </p:txBody>
@@ -12323,7 +12323,7 @@
               </a:defRPr>
             </a:pPr>
             <a:r>
-              <a:t>CHECKED ANSWER</a:t>
+              <a:t>WORKED SOLUTION</a:t>
             </a:r>
           </a:p>
         </p:txBody>
@@ -12544,7 +12544,7 @@
               </a:defRPr>
             </a:pPr>
             <a:r>
-              <a:t>ASK  What gradient would a perfect prediction give? What does that imply for training?</a:t>
+              <a:t>THINK  What gradient would a perfect prediction give? What does that imply for training?</a:t>
             </a:r>
           </a:p>
         </p:txBody>
@@ -22424,7 +22424,7 @@
               </a:defRPr>
             </a:pPr>
             <a:r>
-              <a:t>ASK  Two minutes individually, then compare with a partner.</a:t>
+              <a:t>TRY IT  Two minutes individually, then compare with a partner.</a:t>
             </a:r>
           </a:p>
         </p:txBody>
@@ -23288,7 +23288,7 @@
               </a:defRPr>
             </a:pPr>
             <a:r>
-              <a:t>ASK  Three minutes individually; then explain your reasoning.</a:t>
+              <a:t>TRY IT  Three minutes individually; then explain your reasoning.</a:t>
             </a:r>
           </a:p>
         </p:txBody>
@@ -24585,7 +24585,7 @@
               </a:defRPr>
             </a:pPr>
             <a:r>
-              <a:t>CHECKED ANSWER</a:t>
+              <a:t>WORKED SOLUTION</a:t>
             </a:r>
           </a:p>
         </p:txBody>
@@ -24822,7 +24822,7 @@
               </a:defRPr>
             </a:pPr>
             <a:r>
-              <a:t>ASK  Could two rows rank their classes differently in logits and probabilities?</a:t>
+              <a:t>THINK  Could two rows rank their classes differently in logits and probabilities?</a:t>
             </a:r>
           </a:p>
         </p:txBody>

</xml_diff>

<commit_message>
Remove cue labels from ANN Lecture 4 slide prompts
Co-Authored-By: Claude Opus 5.5 <noreply@anthropic.com>
</commit_message>
<xml_diff>
--- a/courses/artificial-neural-networks/lectures/lecture-04/slides.pptx
+++ b/courses/artificial-neural-networks/lectures/lecture-04/slides.pptx
@@ -7042,7 +7042,7 @@
               </a:defRPr>
             </a:pPr>
             <a:r>
-              <a:t>TRY IT  Three minutes; keep four decimal places.</a:t>
+              <a:t>Three minutes; keep four decimal places.</a:t>
             </a:r>
           </a:p>
         </p:txBody>
@@ -7449,7 +7449,7 @@
               </a:defRPr>
             </a:pPr>
             <a:r>
-              <a:t>THINK  When is a one-hot row more convenient than an index?</a:t>
+              <a:t>When is a one-hot row more convenient than an index?</a:t>
             </a:r>
           </a:p>
         </p:txBody>
@@ -9013,7 +9013,7 @@
               </a:defRPr>
             </a:pPr>
             <a:r>
-              <a:t>TRY IT  Four minutes; ln 2 ≈ 0.693 is a useful anchor.</a:t>
+              <a:t>Four minutes; ln 2 ≈ 0.693 is a useful anchor.</a:t>
             </a:r>
           </a:p>
         </p:txBody>
@@ -9420,7 +9420,7 @@
               </a:defRPr>
             </a:pPr>
             <a:r>
-              <a:t>THINK  Two rows both predict class 0 with p_true = 0.55 and 0.95. Which loss is smaller?</a:t>
+              <a:t>Two rows both predict class 0 with p_true = 0.55 and 0.95. Which loss is smaller?</a:t>
             </a:r>
           </a:p>
         </p:txBody>
@@ -12544,7 +12544,7 @@
               </a:defRPr>
             </a:pPr>
             <a:r>
-              <a:t>THINK  What gradient would a perfect prediction give? What does that imply for training?</a:t>
+              <a:t>What gradient would a perfect prediction give? What does that imply for training?</a:t>
             </a:r>
           </a:p>
         </p:txBody>
@@ -22424,7 +22424,7 @@
               </a:defRPr>
             </a:pPr>
             <a:r>
-              <a:t>TRY IT  Two minutes individually, then compare with a partner.</a:t>
+              <a:t>Two minutes individually, then compare with a partner.</a:t>
             </a:r>
           </a:p>
         </p:txBody>
@@ -23288,7 +23288,7 @@
               </a:defRPr>
             </a:pPr>
             <a:r>
-              <a:t>TRY IT  Three minutes individually; then explain your reasoning.</a:t>
+              <a:t>Three minutes individually; then explain your reasoning.</a:t>
             </a:r>
           </a:p>
         </p:txBody>
@@ -24822,7 +24822,7 @@
               </a:defRPr>
             </a:pPr>
             <a:r>
-              <a:t>THINK  Could two rows rank their classes differently in logits and probabilities?</a:t>
+              <a:t>Could two rows rank their classes differently in logits and probabilities?</a:t>
             </a:r>
           </a:p>
         </p:txBody>

</xml_diff>